<commit_message>
Rebuild persona ads tactic around MOU, pilot and public-private financing
Partner personas (public partners, educators, co-funders, investors, diaspora),
ads B1-B5, five landing pages, and the meetings as the first-stage go-to-market.
Programme-owner version kept as an alternate.

Co-Authored-By: Claude Opus 5.5 <noreply@anthropic.com>
Claude-Session: https://claude.ai/code/session_014DwxjU8rHfrSVBV6irvX7Y
</commit_message>
<xml_diff>
--- a/weekly-tactics/03-persona-ads/NBC_Persona_Ads_Tactic.pptx
+++ b/weekly-tactics/03-persona-ads/NBC_Persona_Ads_Tactic.pptx
@@ -46,9 +46,12 @@
     <p:sldId id="294" r:id="rId40"/>
     <p:sldId id="295" r:id="rId41"/>
     <p:sldId id="296" r:id="rId42"/>
+    <p:sldId id="297" r:id="rId43"/>
+    <p:sldId id="298" r:id="rId44"/>
+    <p:sldId id="299" r:id="rId45"/>
   </p:sldIdLst>
   <p:notesMasterIdLst>
-    <p:notesMasterId r:id="rId43"/>
+    <p:notesMasterId r:id="rId46"/>
   </p:notesMasterIdLst>
   <p:sldSz cx="9144000" cy="5143500"/>
   <p:notesSz cx="5143500" cy="9144000"/>
@@ -3646,6 +3649,270 @@
             <a:fld id="{F7021451-1387-4CA6-816F-3879F97B5CBC}" type="slidenum">
               <a:rPr lang="en-US"/>
               <a:t>41</a:t>
+            </a:fld>
+            <a:endParaRPr lang="en-US"/>
+          </a:p>
+        </p:txBody>
+      </p:sp>
+    </p:spTree>
+    <p:extLst>
+      <p:ext uri="{BB962C8B-B14F-4D97-AF65-F5344CB8AC3E}">
+        <p14:creationId xmlns:p14="http://schemas.microsoft.com/office/powerpoint/2010/main" val="1024086991"/>
+      </p:ext>
+    </p:extLst>
+  </p:cSld>
+  <p:clrMapOvr>
+    <a:masterClrMapping/>
+  </p:clrMapOvr>
+</p:notes>
+</file>
+
+<file path=ppt/notesSlides/notesSlide42.xml><?xml version="1.0" encoding="utf-8"?>
+<p:notes xmlns:a="http://schemas.openxmlformats.org/drawingml/2006/main" xmlns:r="http://schemas.openxmlformats.org/officeDocument/2006/relationships" xmlns:p="http://schemas.openxmlformats.org/presentationml/2006/main">
+  <p:cSld>
+    <p:spTree>
+      <p:nvGrpSpPr>
+        <p:cNvPr id="1" name=""/>
+        <p:cNvGrpSpPr/>
+        <p:nvPr/>
+      </p:nvGrpSpPr>
+      <p:grpSpPr>
+        <a:xfrm>
+          <a:off x="0" y="0"/>
+          <a:ext cx="0" cy="0"/>
+          <a:chOff x="0" y="0"/>
+          <a:chExt cx="0" cy="0"/>
+        </a:xfrm>
+      </p:grpSpPr>
+      <p:sp>
+        <p:nvSpPr>
+          <p:cNvPr id="2" name="Slide Image Placeholder 1"/>
+          <p:cNvSpPr>
+            <a:spLocks noGrp="1" noRot="1" noChangeAspect="1"/>
+          </p:cNvSpPr>
+          <p:nvPr>
+            <p:ph type="sldImg"/>
+          </p:nvPr>
+        </p:nvSpPr>
+        <p:spPr/>
+      </p:sp>
+      <p:sp>
+        <p:nvSpPr>
+          <p:cNvPr id="3" name="Notes Placeholder 2"/>
+          <p:cNvSpPr>
+            <a:spLocks noGrp="1"/>
+          </p:cNvSpPr>
+          <p:nvPr>
+            <p:ph type="body" idx="1"/>
+          </p:nvPr>
+        </p:nvSpPr>
+        <p:spPr/>
+        <p:txBody>
+          <a:bodyPr/>
+          <a:lstStyle/>
+          <a:p>
+            <a:r>
+              <a:rPr lang="en-US" dirty="0"/>
+              <a:t/>
+            </a:r>
+            <a:endParaRPr lang="en-US" dirty="0"/>
+          </a:p>
+        </p:txBody>
+      </p:sp>
+      <p:sp>
+        <p:nvSpPr>
+          <p:cNvPr id="4" name="Slide Number Placeholder 3"/>
+          <p:cNvSpPr>
+            <a:spLocks noGrp="1"/>
+          </p:cNvSpPr>
+          <p:nvPr>
+            <p:ph type="sldNum" sz="quarter" idx="10"/>
+          </p:nvPr>
+        </p:nvSpPr>
+        <p:spPr/>
+        <p:txBody>
+          <a:bodyPr/>
+          <a:lstStyle/>
+          <a:p>
+            <a:fld id="{F7021451-1387-4CA6-816F-3879F97B5CBC}" type="slidenum">
+              <a:rPr lang="en-US"/>
+              <a:t>42</a:t>
+            </a:fld>
+            <a:endParaRPr lang="en-US"/>
+          </a:p>
+        </p:txBody>
+      </p:sp>
+    </p:spTree>
+    <p:extLst>
+      <p:ext uri="{BB962C8B-B14F-4D97-AF65-F5344CB8AC3E}">
+        <p14:creationId xmlns:p14="http://schemas.microsoft.com/office/powerpoint/2010/main" val="1024086991"/>
+      </p:ext>
+    </p:extLst>
+  </p:cSld>
+  <p:clrMapOvr>
+    <a:masterClrMapping/>
+  </p:clrMapOvr>
+</p:notes>
+</file>
+
+<file path=ppt/notesSlides/notesSlide43.xml><?xml version="1.0" encoding="utf-8"?>
+<p:notes xmlns:a="http://schemas.openxmlformats.org/drawingml/2006/main" xmlns:r="http://schemas.openxmlformats.org/officeDocument/2006/relationships" xmlns:p="http://schemas.openxmlformats.org/presentationml/2006/main">
+  <p:cSld>
+    <p:spTree>
+      <p:nvGrpSpPr>
+        <p:cNvPr id="1" name=""/>
+        <p:cNvGrpSpPr/>
+        <p:nvPr/>
+      </p:nvGrpSpPr>
+      <p:grpSpPr>
+        <a:xfrm>
+          <a:off x="0" y="0"/>
+          <a:ext cx="0" cy="0"/>
+          <a:chOff x="0" y="0"/>
+          <a:chExt cx="0" cy="0"/>
+        </a:xfrm>
+      </p:grpSpPr>
+      <p:sp>
+        <p:nvSpPr>
+          <p:cNvPr id="2" name="Slide Image Placeholder 1"/>
+          <p:cNvSpPr>
+            <a:spLocks noGrp="1" noRot="1" noChangeAspect="1"/>
+          </p:cNvSpPr>
+          <p:nvPr>
+            <p:ph type="sldImg"/>
+          </p:nvPr>
+        </p:nvSpPr>
+        <p:spPr/>
+      </p:sp>
+      <p:sp>
+        <p:nvSpPr>
+          <p:cNvPr id="3" name="Notes Placeholder 2"/>
+          <p:cNvSpPr>
+            <a:spLocks noGrp="1"/>
+          </p:cNvSpPr>
+          <p:nvPr>
+            <p:ph type="body" idx="1"/>
+          </p:nvPr>
+        </p:nvSpPr>
+        <p:spPr/>
+        <p:txBody>
+          <a:bodyPr/>
+          <a:lstStyle/>
+          <a:p>
+            <a:r>
+              <a:rPr lang="en-US" dirty="0"/>
+              <a:t/>
+            </a:r>
+            <a:endParaRPr lang="en-US" dirty="0"/>
+          </a:p>
+        </p:txBody>
+      </p:sp>
+      <p:sp>
+        <p:nvSpPr>
+          <p:cNvPr id="4" name="Slide Number Placeholder 3"/>
+          <p:cNvSpPr>
+            <a:spLocks noGrp="1"/>
+          </p:cNvSpPr>
+          <p:nvPr>
+            <p:ph type="sldNum" sz="quarter" idx="10"/>
+          </p:nvPr>
+        </p:nvSpPr>
+        <p:spPr/>
+        <p:txBody>
+          <a:bodyPr/>
+          <a:lstStyle/>
+          <a:p>
+            <a:fld id="{F7021451-1387-4CA6-816F-3879F97B5CBC}" type="slidenum">
+              <a:rPr lang="en-US"/>
+              <a:t>43</a:t>
+            </a:fld>
+            <a:endParaRPr lang="en-US"/>
+          </a:p>
+        </p:txBody>
+      </p:sp>
+    </p:spTree>
+    <p:extLst>
+      <p:ext uri="{BB962C8B-B14F-4D97-AF65-F5344CB8AC3E}">
+        <p14:creationId xmlns:p14="http://schemas.microsoft.com/office/powerpoint/2010/main" val="1024086991"/>
+      </p:ext>
+    </p:extLst>
+  </p:cSld>
+  <p:clrMapOvr>
+    <a:masterClrMapping/>
+  </p:clrMapOvr>
+</p:notes>
+</file>
+
+<file path=ppt/notesSlides/notesSlide44.xml><?xml version="1.0" encoding="utf-8"?>
+<p:notes xmlns:a="http://schemas.openxmlformats.org/drawingml/2006/main" xmlns:r="http://schemas.openxmlformats.org/officeDocument/2006/relationships" xmlns:p="http://schemas.openxmlformats.org/presentationml/2006/main">
+  <p:cSld>
+    <p:spTree>
+      <p:nvGrpSpPr>
+        <p:cNvPr id="1" name=""/>
+        <p:cNvGrpSpPr/>
+        <p:nvPr/>
+      </p:nvGrpSpPr>
+      <p:grpSpPr>
+        <a:xfrm>
+          <a:off x="0" y="0"/>
+          <a:ext cx="0" cy="0"/>
+          <a:chOff x="0" y="0"/>
+          <a:chExt cx="0" cy="0"/>
+        </a:xfrm>
+      </p:grpSpPr>
+      <p:sp>
+        <p:nvSpPr>
+          <p:cNvPr id="2" name="Slide Image Placeholder 1"/>
+          <p:cNvSpPr>
+            <a:spLocks noGrp="1" noRot="1" noChangeAspect="1"/>
+          </p:cNvSpPr>
+          <p:nvPr>
+            <p:ph type="sldImg"/>
+          </p:nvPr>
+        </p:nvSpPr>
+        <p:spPr/>
+      </p:sp>
+      <p:sp>
+        <p:nvSpPr>
+          <p:cNvPr id="3" name="Notes Placeholder 2"/>
+          <p:cNvSpPr>
+            <a:spLocks noGrp="1"/>
+          </p:cNvSpPr>
+          <p:nvPr>
+            <p:ph type="body" idx="1"/>
+          </p:nvPr>
+        </p:nvSpPr>
+        <p:spPr/>
+        <p:txBody>
+          <a:bodyPr/>
+          <a:lstStyle/>
+          <a:p>
+            <a:r>
+              <a:rPr lang="en-US" dirty="0"/>
+              <a:t/>
+            </a:r>
+            <a:endParaRPr lang="en-US" dirty="0"/>
+          </a:p>
+        </p:txBody>
+      </p:sp>
+      <p:sp>
+        <p:nvSpPr>
+          <p:cNvPr id="4" name="Slide Number Placeholder 3"/>
+          <p:cNvSpPr>
+            <a:spLocks noGrp="1"/>
+          </p:cNvSpPr>
+          <p:nvPr>
+            <p:ph type="sldNum" sz="quarter" idx="10"/>
+          </p:nvPr>
+        </p:nvSpPr>
+        <p:spPr/>
+        <p:txBody>
+          <a:bodyPr/>
+          <a:lstStyle/>
+          <a:p>
+            <a:fld id="{F7021451-1387-4CA6-816F-3879F97B5CBC}" type="slidenum">
+              <a:rPr lang="en-US"/>
+              <a:t>44</a:t>
             </a:fld>
             <a:endParaRPr lang="en-US"/>
           </a:p>
@@ -4556,7 +4823,7 @@
       <p:pic>
         <p:nvPicPr>
           <p:cNvPr id="3" name="Image 1" descr="preencoded.png">
-            <a:hlinkClick r:id="rId3" tooltip="https://github.com/samquansah-algo/nbc-vct/blob/main/marketing/INTERVIEW_SCRIPT.md"/>
+            <a:hlinkClick r:id="rId3" tooltip="https://github.com/samquansah-algo/nbc-vct/blob/main/tactics-milestones/DEADLINES.md"/>
           </p:cNvPr>
           <p:cNvPicPr>
             <a:picLocks noChangeAspect="1"/>
@@ -4571,8 +4838,8 @@
         </p:blipFill>
         <p:spPr>
           <a:xfrm>
-            <a:off x="4341019" y="4824412"/>
-            <a:ext cx="638175" cy="109537"/>
+            <a:off x="4698206" y="4824412"/>
+            <a:ext cx="390525" cy="109537"/>
           </a:xfrm>
           <a:prstGeom prst="rect">
             <a:avLst/>
@@ -4582,7 +4849,7 @@
       <p:pic>
         <p:nvPicPr>
           <p:cNvPr id="4" name="Image 2" descr="preencoded.png">
-            <a:hlinkClick r:id="rId5" tooltip="https://github.com/samquansah-algo/nbc-vct/blob/main/marketing/MARKETING_STRATEGY.md"/>
+            <a:hlinkClick r:id="rId5" tooltip="https://github.com/samquansah-algo/nbc-vct/blob/main/brand/NBC_Brand_Guide.pdf"/>
           </p:cNvPr>
           <p:cNvPicPr>
             <a:picLocks noChangeAspect="1"/>
@@ -4597,33 +4864,7 @@
         </p:blipFill>
         <p:spPr>
           <a:xfrm>
-            <a:off x="5041106" y="4824412"/>
-            <a:ext cx="790575" cy="109537"/>
-          </a:xfrm>
-          <a:prstGeom prst="rect">
-            <a:avLst/>
-          </a:prstGeom>
-        </p:spPr>
-      </p:pic>
-      <p:pic>
-        <p:nvPicPr>
-          <p:cNvPr id="5" name="Image 3" descr="preencoded.png">
-            <a:hlinkClick r:id="rId7" tooltip="https://github.com/samquansah-algo/nbc-vct/blob/main/brand/NBC_Brand_Guide.pdf"/>
-          </p:cNvPr>
-          <p:cNvPicPr>
-            <a:picLocks noChangeAspect="1"/>
-          </p:cNvPicPr>
-          <p:nvPr/>
-        </p:nvPicPr>
-        <p:blipFill>
-          <a:blip r:embed="rId6"/>
-          <a:stretch>
-            <a:fillRect/>
-          </a:stretch>
-        </p:blipFill>
-        <p:spPr>
-          <a:xfrm>
-            <a:off x="5893594" y="4824412"/>
+            <a:off x="5150644" y="4824412"/>
             <a:ext cx="642938" cy="109537"/>
           </a:xfrm>
           <a:prstGeom prst="rect">
@@ -4698,7 +4939,7 @@
         </p:blipFill>
         <p:spPr>
           <a:xfrm>
-            <a:off x="5117306" y="4824412"/>
+            <a:off x="4924425" y="4824412"/>
             <a:ext cx="642938" cy="109537"/>
           </a:xfrm>
           <a:prstGeom prst="rect">
@@ -4758,7 +4999,7 @@
       <p:pic>
         <p:nvPicPr>
           <p:cNvPr id="3" name="Image 1" descr="preencoded.png">
-            <a:hlinkClick r:id="rId3" tooltip="https://github.com/samquansah-algo/nbc-vct/tree/main/weekly-tactics/03-persona-ads/"/>
+            <a:hlinkClick r:id="rId3" tooltip="https://github.com/samquansah-algo/nbc-vct/blob/main/marketing/MARKETING_STRATEGY.md"/>
           </p:cNvPr>
           <p:cNvPicPr>
             <a:picLocks noChangeAspect="1"/>
@@ -4773,8 +5014,8 @@
         </p:blipFill>
         <p:spPr>
           <a:xfrm>
-            <a:off x="4791075" y="4824412"/>
-            <a:ext cx="590550" cy="109537"/>
+            <a:off x="4498181" y="4824412"/>
+            <a:ext cx="790575" cy="109537"/>
           </a:xfrm>
           <a:prstGeom prst="rect">
             <a:avLst/>
@@ -4799,7 +5040,7 @@
         </p:blipFill>
         <p:spPr>
           <a:xfrm>
-            <a:off x="5443538" y="4824412"/>
+            <a:off x="5350669" y="4824412"/>
             <a:ext cx="642938" cy="109537"/>
           </a:xfrm>
           <a:prstGeom prst="rect">
@@ -4859,7 +5100,7 @@
       <p:pic>
         <p:nvPicPr>
           <p:cNvPr id="3" name="Image 1" descr="preencoded.png">
-            <a:hlinkClick r:id="rId3" tooltip="https://github.com/samquansah-algo/nbc-vct/tree/main/weekly-tactics/03-persona-ads/"/>
+            <a:hlinkClick r:id="rId3" tooltip="https://github.com/samquansah-algo/nbc-vct/blob/main/brand/NBC_Brand_Guide.pdf"/>
           </p:cNvPr>
           <p:cNvPicPr>
             <a:picLocks noChangeAspect="1"/>
@@ -4874,33 +5115,7 @@
         </p:blipFill>
         <p:spPr>
           <a:xfrm>
-            <a:off x="4791075" y="4824412"/>
-            <a:ext cx="590550" cy="109537"/>
-          </a:xfrm>
-          <a:prstGeom prst="rect">
-            <a:avLst/>
-          </a:prstGeom>
-        </p:spPr>
-      </p:pic>
-      <p:pic>
-        <p:nvPicPr>
-          <p:cNvPr id="4" name="Image 2" descr="preencoded.png">
-            <a:hlinkClick r:id="rId5" tooltip="https://github.com/samquansah-algo/nbc-vct/blob/main/brand/NBC_Brand_Guide.pdf"/>
-          </p:cNvPr>
-          <p:cNvPicPr>
-            <a:picLocks noChangeAspect="1"/>
-          </p:cNvPicPr>
-          <p:nvPr/>
-        </p:nvPicPr>
-        <p:blipFill>
-          <a:blip r:embed="rId4"/>
-          <a:stretch>
-            <a:fillRect/>
-          </a:stretch>
-        </p:blipFill>
-        <p:spPr>
-          <a:xfrm>
-            <a:off x="5443538" y="4824412"/>
+            <a:off x="4924425" y="4824412"/>
             <a:ext cx="642938" cy="109537"/>
           </a:xfrm>
           <a:prstGeom prst="rect">
@@ -4960,7 +5175,7 @@
       <p:pic>
         <p:nvPicPr>
           <p:cNvPr id="3" name="Image 1" descr="preencoded.png">
-            <a:hlinkClick r:id="rId3" tooltip="https://github.com/samquansah-algo/nbc-vct/blob/main/brand/NBC_Brand_Guide.pdf"/>
+            <a:hlinkClick r:id="rId3" tooltip="https://github.com/samquansah-algo/nbc-vct/blob/main/weekly-tactics/03-persona-ads/CAMPAIGN_PLAN.md"/>
           </p:cNvPr>
           <p:cNvPicPr>
             <a:picLocks noChangeAspect="1"/>
@@ -4975,7 +5190,33 @@
         </p:blipFill>
         <p:spPr>
           <a:xfrm>
-            <a:off x="5117306" y="4824412"/>
+            <a:off x="4595812" y="4824412"/>
+            <a:ext cx="595313" cy="109537"/>
+          </a:xfrm>
+          <a:prstGeom prst="rect">
+            <a:avLst/>
+          </a:prstGeom>
+        </p:spPr>
+      </p:pic>
+      <p:pic>
+        <p:nvPicPr>
+          <p:cNvPr id="4" name="Image 2" descr="preencoded.png">
+            <a:hlinkClick r:id="rId5" tooltip="https://github.com/samquansah-algo/nbc-vct/blob/main/brand/NBC_Brand_Guide.pdf"/>
+          </p:cNvPr>
+          <p:cNvPicPr>
+            <a:picLocks noChangeAspect="1"/>
+          </p:cNvPicPr>
+          <p:nvPr/>
+        </p:nvPicPr>
+        <p:blipFill>
+          <a:blip r:embed="rId4"/>
+          <a:stretch>
+            <a:fillRect/>
+          </a:stretch>
+        </p:blipFill>
+        <p:spPr>
+          <a:xfrm>
+            <a:off x="5253037" y="4824412"/>
             <a:ext cx="642938" cy="109537"/>
           </a:xfrm>
           <a:prstGeom prst="rect">
@@ -5035,7 +5276,7 @@
       <p:pic>
         <p:nvPicPr>
           <p:cNvPr id="3" name="Image 1" descr="preencoded.png">
-            <a:hlinkClick r:id="rId3" tooltip="https://github.com/samquansah-algo/nbc-vct/blob/main/weekly-tactics/03-persona-ads/landing-pages/programmes.html"/>
+            <a:hlinkClick r:id="rId3" tooltip="https://github.com/samquansah-algo/nbc-vct/blob/main/weekly-tactics/03-persona-ads/CAMPAIGN_PLAN.md"/>
           </p:cNvPr>
           <p:cNvPicPr>
             <a:picLocks noChangeAspect="1"/>
@@ -5050,8 +5291,8 @@
         </p:blipFill>
         <p:spPr>
           <a:xfrm>
-            <a:off x="4886325" y="2682925"/>
-            <a:ext cx="923925" cy="142875"/>
+            <a:off x="4595812" y="4824412"/>
+            <a:ext cx="595313" cy="109537"/>
           </a:xfrm>
           <a:prstGeom prst="rect">
             <a:avLst/>
@@ -5061,7 +5302,7 @@
       <p:pic>
         <p:nvPicPr>
           <p:cNvPr id="4" name="Image 2" descr="preencoded.png">
-            <a:hlinkClick r:id="rId5" tooltip="https://github.com/samquansah-algo/nbc-vct/blob/main/weekly-tactics/03-persona-ads/ads/A1.png"/>
+            <a:hlinkClick r:id="rId5" tooltip="https://github.com/samquansah-algo/nbc-vct/blob/main/brand/NBC_Brand_Guide.pdf"/>
           </p:cNvPr>
           <p:cNvPicPr>
             <a:picLocks noChangeAspect="1"/>
@@ -5076,33 +5317,7 @@
         </p:blipFill>
         <p:spPr>
           <a:xfrm>
-            <a:off x="4974431" y="4824412"/>
-            <a:ext cx="223838" cy="109537"/>
-          </a:xfrm>
-          <a:prstGeom prst="rect">
-            <a:avLst/>
-          </a:prstGeom>
-        </p:spPr>
-      </p:pic>
-      <p:pic>
-        <p:nvPicPr>
-          <p:cNvPr id="5" name="Image 3" descr="preencoded.png">
-            <a:hlinkClick r:id="rId7" tooltip="https://github.com/samquansah-algo/nbc-vct/blob/main/brand/NBC_Brand_Guide.pdf"/>
-          </p:cNvPr>
-          <p:cNvPicPr>
-            <a:picLocks noChangeAspect="1"/>
-          </p:cNvPicPr>
-          <p:nvPr/>
-        </p:nvPicPr>
-        <p:blipFill>
-          <a:blip r:embed="rId6"/>
-          <a:stretch>
-            <a:fillRect/>
-          </a:stretch>
-        </p:blipFill>
-        <p:spPr>
-          <a:xfrm>
-            <a:off x="5260181" y="4824412"/>
+            <a:off x="5253037" y="4824412"/>
             <a:ext cx="642938" cy="109537"/>
           </a:xfrm>
           <a:prstGeom prst="rect">
@@ -5162,7 +5377,7 @@
       <p:pic>
         <p:nvPicPr>
           <p:cNvPr id="3" name="Image 1" descr="preencoded.png">
-            <a:hlinkClick r:id="rId3" tooltip="https://github.com/samquansah-algo/nbc-vct/blob/main/weekly-tactics/03-persona-ads/landing-pages/programmes.html"/>
+            <a:hlinkClick r:id="rId3" tooltip="https://github.com/samquansah-algo/nbc-vct/blob/main/brand/NBC_Brand_Guide.pdf"/>
           </p:cNvPr>
           <p:cNvPicPr>
             <a:picLocks noChangeAspect="1"/>
@@ -5177,59 +5392,7 @@
         </p:blipFill>
         <p:spPr>
           <a:xfrm>
-            <a:off x="4886325" y="2682925"/>
-            <a:ext cx="923925" cy="142875"/>
-          </a:xfrm>
-          <a:prstGeom prst="rect">
-            <a:avLst/>
-          </a:prstGeom>
-        </p:spPr>
-      </p:pic>
-      <p:pic>
-        <p:nvPicPr>
-          <p:cNvPr id="4" name="Image 2" descr="preencoded.png">
-            <a:hlinkClick r:id="rId5" tooltip="https://github.com/samquansah-algo/nbc-vct/blob/main/weekly-tactics/03-persona-ads/ads/A2.png"/>
-          </p:cNvPr>
-          <p:cNvPicPr>
-            <a:picLocks noChangeAspect="1"/>
-          </p:cNvPicPr>
-          <p:nvPr/>
-        </p:nvPicPr>
-        <p:blipFill>
-          <a:blip r:embed="rId4"/>
-          <a:stretch>
-            <a:fillRect/>
-          </a:stretch>
-        </p:blipFill>
-        <p:spPr>
-          <a:xfrm>
-            <a:off x="4974431" y="4824412"/>
-            <a:ext cx="223838" cy="109537"/>
-          </a:xfrm>
-          <a:prstGeom prst="rect">
-            <a:avLst/>
-          </a:prstGeom>
-        </p:spPr>
-      </p:pic>
-      <p:pic>
-        <p:nvPicPr>
-          <p:cNvPr id="5" name="Image 3" descr="preencoded.png">
-            <a:hlinkClick r:id="rId7" tooltip="https://github.com/samquansah-algo/nbc-vct/blob/main/brand/NBC_Brand_Guide.pdf"/>
-          </p:cNvPr>
-          <p:cNvPicPr>
-            <a:picLocks noChangeAspect="1"/>
-          </p:cNvPicPr>
-          <p:nvPr/>
-        </p:nvPicPr>
-        <p:blipFill>
-          <a:blip r:embed="rId6"/>
-          <a:stretch>
-            <a:fillRect/>
-          </a:stretch>
-        </p:blipFill>
-        <p:spPr>
-          <a:xfrm>
-            <a:off x="5260181" y="4824412"/>
+            <a:off x="4924425" y="4824412"/>
             <a:ext cx="642938" cy="109537"/>
           </a:xfrm>
           <a:prstGeom prst="rect">
@@ -5289,7 +5452,7 @@
       <p:pic>
         <p:nvPicPr>
           <p:cNvPr id="3" name="Image 1" descr="preencoded.png">
-            <a:hlinkClick r:id="rId3" tooltip="https://github.com/samquansah-algo/nbc-vct/blob/main/weekly-tactics/03-persona-ads/landing-pages/educators.html"/>
+            <a:hlinkClick r:id="rId3" tooltip="https://github.com/samquansah-algo/nbc-vct/blob/main/weekly-tactics/03-persona-ads/landing-pages/government.html"/>
           </p:cNvPr>
           <p:cNvPicPr>
             <a:picLocks noChangeAspect="1"/>
@@ -5305,7 +5468,7 @@
         <p:spPr>
           <a:xfrm>
             <a:off x="4886325" y="2682925"/>
-            <a:ext cx="771525" cy="142875"/>
+            <a:ext cx="885825" cy="142875"/>
           </a:xfrm>
           <a:prstGeom prst="rect">
             <a:avLst/>
@@ -5315,7 +5478,7 @@
       <p:pic>
         <p:nvPicPr>
           <p:cNvPr id="4" name="Image 2" descr="preencoded.png">
-            <a:hlinkClick r:id="rId5" tooltip="https://github.com/samquansah-algo/nbc-vct/blob/main/weekly-tactics/03-persona-ads/ads/A3.png"/>
+            <a:hlinkClick r:id="rId5" tooltip="https://github.com/samquansah-algo/nbc-vct/blob/main/weekly-tactics/03-persona-ads/ads/B1.png"/>
           </p:cNvPr>
           <p:cNvPicPr>
             <a:picLocks noChangeAspect="1"/>
@@ -5330,8 +5493,8 @@
         </p:blipFill>
         <p:spPr>
           <a:xfrm>
-            <a:off x="4974431" y="4824412"/>
-            <a:ext cx="223838" cy="109537"/>
+            <a:off x="4783931" y="4824412"/>
+            <a:ext cx="219075" cy="109537"/>
           </a:xfrm>
           <a:prstGeom prst="rect">
             <a:avLst/>
@@ -5356,7 +5519,7 @@
         </p:blipFill>
         <p:spPr>
           <a:xfrm>
-            <a:off x="5260181" y="4824412"/>
+            <a:off x="5064919" y="4824412"/>
             <a:ext cx="642938" cy="109537"/>
           </a:xfrm>
           <a:prstGeom prst="rect">
@@ -5416,7 +5579,7 @@
       <p:pic>
         <p:nvPicPr>
           <p:cNvPr id="3" name="Image 1" descr="preencoded.png">
-            <a:hlinkClick r:id="rId3" tooltip="https://github.com/samquansah-algo/nbc-vct/blob/main/weekly-tactics/03-persona-ads/landing-pages/families.html"/>
+            <a:hlinkClick r:id="rId3" tooltip="https://github.com/samquansah-algo/nbc-vct/blob/main/weekly-tactics/03-persona-ads/landing-pages/educators.html"/>
           </p:cNvPr>
           <p:cNvPicPr>
             <a:picLocks noChangeAspect="1"/>
@@ -5432,7 +5595,7 @@
         <p:spPr>
           <a:xfrm>
             <a:off x="4886325" y="2682925"/>
-            <a:ext cx="666750" cy="142875"/>
+            <a:ext cx="771525" cy="142875"/>
           </a:xfrm>
           <a:prstGeom prst="rect">
             <a:avLst/>
@@ -5442,7 +5605,7 @@
       <p:pic>
         <p:nvPicPr>
           <p:cNvPr id="4" name="Image 2" descr="preencoded.png">
-            <a:hlinkClick r:id="rId5" tooltip="https://github.com/samquansah-algo/nbc-vct/blob/main/weekly-tactics/03-persona-ads/ads/A4.png"/>
+            <a:hlinkClick r:id="rId5" tooltip="https://github.com/samquansah-algo/nbc-vct/blob/main/weekly-tactics/03-persona-ads/ads/B2.png"/>
           </p:cNvPr>
           <p:cNvPicPr>
             <a:picLocks noChangeAspect="1"/>
@@ -5457,8 +5620,8 @@
         </p:blipFill>
         <p:spPr>
           <a:xfrm>
-            <a:off x="4974431" y="4824412"/>
-            <a:ext cx="223838" cy="109537"/>
+            <a:off x="4783931" y="4824412"/>
+            <a:ext cx="219075" cy="109537"/>
           </a:xfrm>
           <a:prstGeom prst="rect">
             <a:avLst/>
@@ -5483,7 +5646,7 @@
         </p:blipFill>
         <p:spPr>
           <a:xfrm>
-            <a:off x="5260181" y="4824412"/>
+            <a:off x="5064919" y="4824412"/>
             <a:ext cx="642938" cy="109537"/>
           </a:xfrm>
           <a:prstGeom prst="rect">
@@ -5543,7 +5706,7 @@
       <p:pic>
         <p:nvPicPr>
           <p:cNvPr id="3" name="Image 1" descr="preencoded.png">
-            <a:hlinkClick r:id="rId3" tooltip="https://github.com/samquansah-algo/nbc-vct/blob/main/weekly-tactics/03-persona-ads/landing-pages/sponsors.html"/>
+            <a:hlinkClick r:id="rId3" tooltip="https://github.com/samquansah-algo/nbc-vct/blob/main/weekly-tactics/03-persona-ads/landing-pages/partners.html"/>
           </p:cNvPr>
           <p:cNvPicPr>
             <a:picLocks noChangeAspect="1"/>
@@ -5559,7 +5722,7 @@
         <p:spPr>
           <a:xfrm>
             <a:off x="4886325" y="2682925"/>
-            <a:ext cx="733425" cy="142875"/>
+            <a:ext cx="700088" cy="142875"/>
           </a:xfrm>
           <a:prstGeom prst="rect">
             <a:avLst/>
@@ -5569,7 +5732,7 @@
       <p:pic>
         <p:nvPicPr>
           <p:cNvPr id="4" name="Image 2" descr="preencoded.png">
-            <a:hlinkClick r:id="rId5" tooltip="https://github.com/samquansah-algo/nbc-vct/blob/main/weekly-tactics/03-persona-ads/ads/A5.png"/>
+            <a:hlinkClick r:id="rId5" tooltip="https://github.com/samquansah-algo/nbc-vct/blob/main/weekly-tactics/03-persona-ads/ads/B3.png"/>
           </p:cNvPr>
           <p:cNvPicPr>
             <a:picLocks noChangeAspect="1"/>
@@ -5584,8 +5747,8 @@
         </p:blipFill>
         <p:spPr>
           <a:xfrm>
-            <a:off x="4974431" y="4824412"/>
-            <a:ext cx="223838" cy="109537"/>
+            <a:off x="4783931" y="4824412"/>
+            <a:ext cx="219075" cy="109537"/>
           </a:xfrm>
           <a:prstGeom prst="rect">
             <a:avLst/>
@@ -5610,7 +5773,7 @@
         </p:blipFill>
         <p:spPr>
           <a:xfrm>
-            <a:off x="5260181" y="4824412"/>
+            <a:off x="5064919" y="4824412"/>
             <a:ext cx="642938" cy="109537"/>
           </a:xfrm>
           <a:prstGeom prst="rect">
@@ -5685,7 +5848,7 @@
         </p:blipFill>
         <p:spPr>
           <a:xfrm>
-            <a:off x="4931569" y="4824412"/>
+            <a:off x="4738687" y="4824412"/>
             <a:ext cx="357188" cy="109537"/>
           </a:xfrm>
           <a:prstGeom prst="rect">
@@ -5711,7 +5874,7 @@
         </p:blipFill>
         <p:spPr>
           <a:xfrm>
-            <a:off x="5350669" y="4824412"/>
+            <a:off x="5157788" y="4824412"/>
             <a:ext cx="642938" cy="109537"/>
           </a:xfrm>
           <a:prstGeom prst="rect">
@@ -5771,7 +5934,7 @@
       <p:pic>
         <p:nvPicPr>
           <p:cNvPr id="3" name="Image 1" descr="preencoded.png">
-            <a:hlinkClick r:id="rId3" tooltip="https://github.com/samquansah-algo/nbc-vct/blob/main/brand/NBC_Brand_Guide.pdf"/>
+            <a:hlinkClick r:id="rId3" tooltip="https://github.com/samquansah-algo/nbc-vct/blob/main/weekly-tactics/03-persona-ads/landing-pages/investors.html"/>
           </p:cNvPr>
           <p:cNvPicPr>
             <a:picLocks noChangeAspect="1"/>
@@ -5786,7 +5949,59 @@
         </p:blipFill>
         <p:spPr>
           <a:xfrm>
-            <a:off x="5117306" y="4824412"/>
+            <a:off x="4886325" y="2682925"/>
+            <a:ext cx="728663" cy="142875"/>
+          </a:xfrm>
+          <a:prstGeom prst="rect">
+            <a:avLst/>
+          </a:prstGeom>
+        </p:spPr>
+      </p:pic>
+      <p:pic>
+        <p:nvPicPr>
+          <p:cNvPr id="4" name="Image 2" descr="preencoded.png">
+            <a:hlinkClick r:id="rId5" tooltip="https://github.com/samquansah-algo/nbc-vct/blob/main/weekly-tactics/03-persona-ads/ads/B4.png"/>
+          </p:cNvPr>
+          <p:cNvPicPr>
+            <a:picLocks noChangeAspect="1"/>
+          </p:cNvPicPr>
+          <p:nvPr/>
+        </p:nvPicPr>
+        <p:blipFill>
+          <a:blip r:embed="rId4"/>
+          <a:stretch>
+            <a:fillRect/>
+          </a:stretch>
+        </p:blipFill>
+        <p:spPr>
+          <a:xfrm>
+            <a:off x="4783931" y="4824412"/>
+            <a:ext cx="219075" cy="109537"/>
+          </a:xfrm>
+          <a:prstGeom prst="rect">
+            <a:avLst/>
+          </a:prstGeom>
+        </p:spPr>
+      </p:pic>
+      <p:pic>
+        <p:nvPicPr>
+          <p:cNvPr id="5" name="Image 3" descr="preencoded.png">
+            <a:hlinkClick r:id="rId7" tooltip="https://github.com/samquansah-algo/nbc-vct/blob/main/brand/NBC_Brand_Guide.pdf"/>
+          </p:cNvPr>
+          <p:cNvPicPr>
+            <a:picLocks noChangeAspect="1"/>
+          </p:cNvPicPr>
+          <p:nvPr/>
+        </p:nvPicPr>
+        <p:blipFill>
+          <a:blip r:embed="rId6"/>
+          <a:stretch>
+            <a:fillRect/>
+          </a:stretch>
+        </p:blipFill>
+        <p:spPr>
+          <a:xfrm>
+            <a:off x="5064919" y="4824412"/>
             <a:ext cx="642938" cy="109537"/>
           </a:xfrm>
           <a:prstGeom prst="rect">
@@ -5846,7 +6061,7 @@
       <p:pic>
         <p:nvPicPr>
           <p:cNvPr id="3" name="Image 1" descr="preencoded.png">
-            <a:hlinkClick r:id="rId3" tooltip="https://github.com/samquansah-algo/nbc-vct/blob/main/weekly-tactics/03-persona-ads/landing-pages/programmes.html"/>
+            <a:hlinkClick r:id="rId3" tooltip="https://github.com/samquansah-algo/nbc-vct/blob/main/weekly-tactics/03-persona-ads/landing-pages/sponsors.html"/>
           </p:cNvPr>
           <p:cNvPicPr>
             <a:picLocks noChangeAspect="1"/>
@@ -5861,8 +6076,8 @@
         </p:blipFill>
         <p:spPr>
           <a:xfrm>
-            <a:off x="4710112" y="4824412"/>
-            <a:ext cx="752475" cy="109537"/>
+            <a:off x="4886325" y="2682925"/>
+            <a:ext cx="733425" cy="142875"/>
           </a:xfrm>
           <a:prstGeom prst="rect">
             <a:avLst/>
@@ -5872,7 +6087,7 @@
       <p:pic>
         <p:nvPicPr>
           <p:cNvPr id="4" name="Image 2" descr="preencoded.png">
-            <a:hlinkClick r:id="rId5" tooltip="https://github.com/samquansah-algo/nbc-vct/blob/main/brand/NBC_Brand_Guide.pdf"/>
+            <a:hlinkClick r:id="rId5" tooltip="https://github.com/samquansah-algo/nbc-vct/blob/main/weekly-tactics/03-persona-ads/ads/B5.png"/>
           </p:cNvPr>
           <p:cNvPicPr>
             <a:picLocks noChangeAspect="1"/>
@@ -5887,7 +6102,33 @@
         </p:blipFill>
         <p:spPr>
           <a:xfrm>
-            <a:off x="5524500" y="4824412"/>
+            <a:off x="4783931" y="4824412"/>
+            <a:ext cx="219075" cy="109537"/>
+          </a:xfrm>
+          <a:prstGeom prst="rect">
+            <a:avLst/>
+          </a:prstGeom>
+        </p:spPr>
+      </p:pic>
+      <p:pic>
+        <p:nvPicPr>
+          <p:cNvPr id="5" name="Image 3" descr="preencoded.png">
+            <a:hlinkClick r:id="rId7" tooltip="https://github.com/samquansah-algo/nbc-vct/blob/main/brand/NBC_Brand_Guide.pdf"/>
+          </p:cNvPr>
+          <p:cNvPicPr>
+            <a:picLocks noChangeAspect="1"/>
+          </p:cNvPicPr>
+          <p:nvPr/>
+        </p:nvPicPr>
+        <p:blipFill>
+          <a:blip r:embed="rId6"/>
+          <a:stretch>
+            <a:fillRect/>
+          </a:stretch>
+        </p:blipFill>
+        <p:spPr>
+          <a:xfrm>
+            <a:off x="5064919" y="4824412"/>
             <a:ext cx="642938" cy="109537"/>
           </a:xfrm>
           <a:prstGeom prst="rect">
@@ -5947,7 +6188,7 @@
       <p:pic>
         <p:nvPicPr>
           <p:cNvPr id="3" name="Image 1" descr="preencoded.png">
-            <a:hlinkClick r:id="rId3" tooltip="https://github.com/samquansah-algo/nbc-vct/blob/main/weekly-tactics/03-persona-ads/landing-pages/educators.html"/>
+            <a:hlinkClick r:id="rId3" tooltip="https://github.com/samquansah-algo/nbc-vct/blob/main/brand/NBC_Brand_Guide.pdf"/>
           </p:cNvPr>
           <p:cNvPicPr>
             <a:picLocks noChangeAspect="1"/>
@@ -5962,33 +6203,7 @@
         </p:blipFill>
         <p:spPr>
           <a:xfrm>
-            <a:off x="4772025" y="4824412"/>
-            <a:ext cx="628650" cy="109537"/>
-          </a:xfrm>
-          <a:prstGeom prst="rect">
-            <a:avLst/>
-          </a:prstGeom>
-        </p:spPr>
-      </p:pic>
-      <p:pic>
-        <p:nvPicPr>
-          <p:cNvPr id="4" name="Image 2" descr="preencoded.png">
-            <a:hlinkClick r:id="rId5" tooltip="https://github.com/samquansah-algo/nbc-vct/blob/main/brand/NBC_Brand_Guide.pdf"/>
-          </p:cNvPr>
-          <p:cNvPicPr>
-            <a:picLocks noChangeAspect="1"/>
-          </p:cNvPicPr>
-          <p:nvPr/>
-        </p:nvPicPr>
-        <p:blipFill>
-          <a:blip r:embed="rId4"/>
-          <a:stretch>
-            <a:fillRect/>
-          </a:stretch>
-        </p:blipFill>
-        <p:spPr>
-          <a:xfrm>
-            <a:off x="5462588" y="4824412"/>
+            <a:off x="4924425" y="4824412"/>
             <a:ext cx="642938" cy="109537"/>
           </a:xfrm>
           <a:prstGeom prst="rect">
@@ -6048,7 +6263,7 @@
       <p:pic>
         <p:nvPicPr>
           <p:cNvPr id="3" name="Image 1" descr="preencoded.png">
-            <a:hlinkClick r:id="rId3" tooltip="https://github.com/samquansah-algo/nbc-vct/blob/main/weekly-tactics/03-persona-ads/landing-pages/families.html"/>
+            <a:hlinkClick r:id="rId3" tooltip="https://github.com/samquansah-algo/nbc-vct/blob/main/weekly-tactics/03-persona-ads/landing-pages/government.html"/>
           </p:cNvPr>
           <p:cNvPicPr>
             <a:picLocks noChangeAspect="1"/>
@@ -6063,8 +6278,8 @@
         </p:blipFill>
         <p:spPr>
           <a:xfrm>
-            <a:off x="4814888" y="4824412"/>
-            <a:ext cx="542925" cy="109537"/>
+            <a:off x="4531519" y="4824412"/>
+            <a:ext cx="723900" cy="109537"/>
           </a:xfrm>
           <a:prstGeom prst="rect">
             <a:avLst/>
@@ -6089,7 +6304,7 @@
         </p:blipFill>
         <p:spPr>
           <a:xfrm>
-            <a:off x="5419725" y="4824412"/>
+            <a:off x="5317331" y="4824412"/>
             <a:ext cx="642938" cy="109537"/>
           </a:xfrm>
           <a:prstGeom prst="rect">
@@ -6149,7 +6364,7 @@
       <p:pic>
         <p:nvPicPr>
           <p:cNvPr id="3" name="Image 1" descr="preencoded.png">
-            <a:hlinkClick r:id="rId3" tooltip="https://github.com/samquansah-algo/nbc-vct/blob/main/weekly-tactics/03-persona-ads/landing-pages/sponsors.html"/>
+            <a:hlinkClick r:id="rId3" tooltip="https://github.com/samquansah-algo/nbc-vct/blob/main/weekly-tactics/03-persona-ads/landing-pages/educators.html"/>
           </p:cNvPr>
           <p:cNvPicPr>
             <a:picLocks noChangeAspect="1"/>
@@ -6164,8 +6379,8 @@
         </p:blipFill>
         <p:spPr>
           <a:xfrm>
-            <a:off x="4788694" y="4824412"/>
-            <a:ext cx="595313" cy="109537"/>
+            <a:off x="4579144" y="4824412"/>
+            <a:ext cx="628650" cy="109537"/>
           </a:xfrm>
           <a:prstGeom prst="rect">
             <a:avLst/>
@@ -6190,7 +6405,7 @@
         </p:blipFill>
         <p:spPr>
           <a:xfrm>
-            <a:off x="5445919" y="4824412"/>
+            <a:off x="5269706" y="4824412"/>
             <a:ext cx="642938" cy="109537"/>
           </a:xfrm>
           <a:prstGeom prst="rect">
@@ -6250,7 +6465,7 @@
       <p:pic>
         <p:nvPicPr>
           <p:cNvPr id="3" name="Image 1" descr="preencoded.png">
-            <a:hlinkClick r:id="rId3" tooltip="https://github.com/samquansah-algo/nbc-vct/blob/main/brand/NBC_Brand_Guide.pdf"/>
+            <a:hlinkClick r:id="rId3" tooltip="https://github.com/samquansah-algo/nbc-vct/blob/main/weekly-tactics/03-persona-ads/landing-pages/partners.html"/>
           </p:cNvPr>
           <p:cNvPicPr>
             <a:picLocks noChangeAspect="1"/>
@@ -6265,7 +6480,33 @@
         </p:blipFill>
         <p:spPr>
           <a:xfrm>
-            <a:off x="5117306" y="4824412"/>
+            <a:off x="4607719" y="4824412"/>
+            <a:ext cx="571500" cy="109537"/>
+          </a:xfrm>
+          <a:prstGeom prst="rect">
+            <a:avLst/>
+          </a:prstGeom>
+        </p:spPr>
+      </p:pic>
+      <p:pic>
+        <p:nvPicPr>
+          <p:cNvPr id="4" name="Image 2" descr="preencoded.png">
+            <a:hlinkClick r:id="rId5" tooltip="https://github.com/samquansah-algo/nbc-vct/blob/main/brand/NBC_Brand_Guide.pdf"/>
+          </p:cNvPr>
+          <p:cNvPicPr>
+            <a:picLocks noChangeAspect="1"/>
+          </p:cNvPicPr>
+          <p:nvPr/>
+        </p:nvPicPr>
+        <p:blipFill>
+          <a:blip r:embed="rId4"/>
+          <a:stretch>
+            <a:fillRect/>
+          </a:stretch>
+        </p:blipFill>
+        <p:spPr>
+          <a:xfrm>
+            <a:off x="5241131" y="4824412"/>
             <a:ext cx="642938" cy="109537"/>
           </a:xfrm>
           <a:prstGeom prst="rect">
@@ -6325,7 +6566,7 @@
       <p:pic>
         <p:nvPicPr>
           <p:cNvPr id="3" name="Image 1" descr="preencoded.png">
-            <a:hlinkClick r:id="rId3" tooltip="https://github.com/samquansah-algo/nbc-vct/blob/main/weekly-tactics/03-persona-ads/CAMPAIGN_PLAN.md"/>
+            <a:hlinkClick r:id="rId3" tooltip="https://github.com/samquansah-algo/nbc-vct/blob/main/weekly-tactics/03-persona-ads/landing-pages/investors.html"/>
           </p:cNvPr>
           <p:cNvPicPr>
             <a:picLocks noChangeAspect="1"/>
@@ -6340,8 +6581,8 @@
         </p:blipFill>
         <p:spPr>
           <a:xfrm>
-            <a:off x="4874419" y="4824412"/>
-            <a:ext cx="423862" cy="109537"/>
+            <a:off x="4593431" y="4824412"/>
+            <a:ext cx="600075" cy="109537"/>
           </a:xfrm>
           <a:prstGeom prst="rect">
             <a:avLst/>
@@ -6366,7 +6607,7 @@
         </p:blipFill>
         <p:spPr>
           <a:xfrm>
-            <a:off x="5360194" y="4824412"/>
+            <a:off x="5255419" y="4824412"/>
             <a:ext cx="642938" cy="109537"/>
           </a:xfrm>
           <a:prstGeom prst="rect">
@@ -6426,7 +6667,7 @@
       <p:pic>
         <p:nvPicPr>
           <p:cNvPr id="3" name="Image 1" descr="preencoded.png">
-            <a:hlinkClick r:id="rId3" tooltip="https://github.com/samquansah-algo/nbc-vct/blob/main/weekly-tactics/03-persona-ads/CAMPAIGN_PLAN.md"/>
+            <a:hlinkClick r:id="rId3" tooltip="https://github.com/samquansah-algo/nbc-vct/blob/main/weekly-tactics/03-persona-ads/landing-pages/sponsors.html"/>
           </p:cNvPr>
           <p:cNvPicPr>
             <a:picLocks noChangeAspect="1"/>
@@ -6441,8 +6682,8 @@
         </p:blipFill>
         <p:spPr>
           <a:xfrm>
-            <a:off x="4874419" y="4824412"/>
-            <a:ext cx="423862" cy="109537"/>
+            <a:off x="4595812" y="4824412"/>
+            <a:ext cx="595313" cy="109537"/>
           </a:xfrm>
           <a:prstGeom prst="rect">
             <a:avLst/>
@@ -6467,7 +6708,7 @@
         </p:blipFill>
         <p:spPr>
           <a:xfrm>
-            <a:off x="5360194" y="4824412"/>
+            <a:off x="5253037" y="4824412"/>
             <a:ext cx="642938" cy="109537"/>
           </a:xfrm>
           <a:prstGeom prst="rect">
@@ -6527,7 +6768,7 @@
       <p:pic>
         <p:nvPicPr>
           <p:cNvPr id="3" name="Image 1" descr="preencoded.png">
-            <a:hlinkClick r:id="rId3" tooltip="https://github.com/samquansah-algo/nbc-vct/blob/main/weekly-tactics/03-persona-ads/CAMPAIGN_PLAN.md"/>
+            <a:hlinkClick r:id="rId3" tooltip="https://github.com/samquansah-algo/nbc-vct/blob/main/brand/NBC_Brand_Guide.pdf"/>
           </p:cNvPr>
           <p:cNvPicPr>
             <a:picLocks noChangeAspect="1"/>
@@ -6542,33 +6783,7 @@
         </p:blipFill>
         <p:spPr>
           <a:xfrm>
-            <a:off x="4874419" y="4824412"/>
-            <a:ext cx="423862" cy="109537"/>
-          </a:xfrm>
-          <a:prstGeom prst="rect">
-            <a:avLst/>
-          </a:prstGeom>
-        </p:spPr>
-      </p:pic>
-      <p:pic>
-        <p:nvPicPr>
-          <p:cNvPr id="4" name="Image 2" descr="preencoded.png">
-            <a:hlinkClick r:id="rId5" tooltip="https://github.com/samquansah-algo/nbc-vct/blob/main/brand/NBC_Brand_Guide.pdf"/>
-          </p:cNvPr>
-          <p:cNvPicPr>
-            <a:picLocks noChangeAspect="1"/>
-          </p:cNvPicPr>
-          <p:nvPr/>
-        </p:nvPicPr>
-        <p:blipFill>
-          <a:blip r:embed="rId4"/>
-          <a:stretch>
-            <a:fillRect/>
-          </a:stretch>
-        </p:blipFill>
-        <p:spPr>
-          <a:xfrm>
-            <a:off x="5360194" y="4824412"/>
+            <a:off x="4924425" y="4824412"/>
             <a:ext cx="642938" cy="109537"/>
           </a:xfrm>
           <a:prstGeom prst="rect">
@@ -6628,7 +6843,7 @@
       <p:pic>
         <p:nvPicPr>
           <p:cNvPr id="3" name="Image 1" descr="preencoded.png">
-            <a:hlinkClick r:id="rId3" tooltip="https://github.com/samquansah-algo/nbc-vct/blob/main/brand/NBC_Brand_Guide.pdf"/>
+            <a:hlinkClick r:id="rId3" tooltip="https://github.com/samquansah-algo/nbc-vct/blob/main/weekly-tactics/03-persona-ads/CAMPAIGN_PLAN.md"/>
           </p:cNvPr>
           <p:cNvPicPr>
             <a:picLocks noChangeAspect="1"/>
@@ -6643,7 +6858,33 @@
         </p:blipFill>
         <p:spPr>
           <a:xfrm>
-            <a:off x="5117306" y="4824412"/>
+            <a:off x="4595812" y="4824412"/>
+            <a:ext cx="595313" cy="109537"/>
+          </a:xfrm>
+          <a:prstGeom prst="rect">
+            <a:avLst/>
+          </a:prstGeom>
+        </p:spPr>
+      </p:pic>
+      <p:pic>
+        <p:nvPicPr>
+          <p:cNvPr id="4" name="Image 2" descr="preencoded.png">
+            <a:hlinkClick r:id="rId5" tooltip="https://github.com/samquansah-algo/nbc-vct/blob/main/brand/NBC_Brand_Guide.pdf"/>
+          </p:cNvPr>
+          <p:cNvPicPr>
+            <a:picLocks noChangeAspect="1"/>
+          </p:cNvPicPr>
+          <p:nvPr/>
+        </p:nvPicPr>
+        <p:blipFill>
+          <a:blip r:embed="rId4"/>
+          <a:stretch>
+            <a:fillRect/>
+          </a:stretch>
+        </p:blipFill>
+        <p:spPr>
+          <a:xfrm>
+            <a:off x="5253037" y="4824412"/>
             <a:ext cx="642938" cy="109537"/>
           </a:xfrm>
           <a:prstGeom prst="rect">
@@ -6718,7 +6959,7 @@
         </p:blipFill>
         <p:spPr>
           <a:xfrm>
-            <a:off x="4772025" y="4824412"/>
+            <a:off x="4579144" y="4824412"/>
             <a:ext cx="676275" cy="109537"/>
           </a:xfrm>
           <a:prstGeom prst="rect">
@@ -6744,7 +6985,7 @@
         </p:blipFill>
         <p:spPr>
           <a:xfrm>
-            <a:off x="5510212" y="4824412"/>
+            <a:off x="5317331" y="4824412"/>
             <a:ext cx="642938" cy="109537"/>
           </a:xfrm>
           <a:prstGeom prst="rect">
@@ -6804,7 +7045,7 @@
       <p:pic>
         <p:nvPicPr>
           <p:cNvPr id="3" name="Image 1" descr="preencoded.png">
-            <a:hlinkClick r:id="rId3" tooltip="https://github.com/samquansah-algo/nbc-vct/blob/main/weekly-tactics/03-persona-ads/CAMPAIGN_PLAN.md#results"/>
+            <a:hlinkClick r:id="rId3" tooltip="https://github.com/samquansah-algo/nbc-vct/blob/main/weekly-tactics/03-persona-ads/CAMPAIGN_PLAN.md"/>
           </p:cNvPr>
           <p:cNvPicPr>
             <a:picLocks noChangeAspect="1"/>
@@ -6819,8 +7060,8 @@
         </p:blipFill>
         <p:spPr>
           <a:xfrm>
-            <a:off x="4872038" y="4824412"/>
-            <a:ext cx="428625" cy="109537"/>
+            <a:off x="4595812" y="4824412"/>
+            <a:ext cx="595313" cy="109537"/>
           </a:xfrm>
           <a:prstGeom prst="rect">
             <a:avLst/>
@@ -6845,7 +7086,7 @@
         </p:blipFill>
         <p:spPr>
           <a:xfrm>
-            <a:off x="5362575" y="4824412"/>
+            <a:off x="5253037" y="4824412"/>
             <a:ext cx="642938" cy="109537"/>
           </a:xfrm>
           <a:prstGeom prst="rect">
@@ -6920,7 +7161,7 @@
         </p:blipFill>
         <p:spPr>
           <a:xfrm>
-            <a:off x="4788694" y="4824412"/>
+            <a:off x="4595812" y="4824412"/>
             <a:ext cx="595313" cy="109537"/>
           </a:xfrm>
           <a:prstGeom prst="rect">
@@ -6946,7 +7187,7 @@
         </p:blipFill>
         <p:spPr>
           <a:xfrm>
-            <a:off x="5445919" y="4824412"/>
+            <a:off x="5253037" y="4824412"/>
             <a:ext cx="642938" cy="109537"/>
           </a:xfrm>
           <a:prstGeom prst="rect">
@@ -7006,7 +7247,7 @@
       <p:pic>
         <p:nvPicPr>
           <p:cNvPr id="3" name="Image 1" descr="preencoded.png">
-            <a:hlinkClick r:id="rId3" tooltip="https://github.com/samquansah-algo/nbc-vct/blob/main/tactics-milestones/WEEKLY_DECISION_RECORD.md"/>
+            <a:hlinkClick r:id="rId3" tooltip="https://github.com/samquansah-algo/nbc-vct/blob/main/brand/NBC_Brand_Guide.pdf"/>
           </p:cNvPr>
           <p:cNvPicPr>
             <a:picLocks noChangeAspect="1"/>
@@ -7021,33 +7262,7 @@
         </p:blipFill>
         <p:spPr>
           <a:xfrm>
-            <a:off x="4772025" y="4824412"/>
-            <a:ext cx="628650" cy="109537"/>
-          </a:xfrm>
-          <a:prstGeom prst="rect">
-            <a:avLst/>
-          </a:prstGeom>
-        </p:spPr>
-      </p:pic>
-      <p:pic>
-        <p:nvPicPr>
-          <p:cNvPr id="4" name="Image 2" descr="preencoded.png">
-            <a:hlinkClick r:id="rId5" tooltip="https://github.com/samquansah-algo/nbc-vct/blob/main/brand/NBC_Brand_Guide.pdf"/>
-          </p:cNvPr>
-          <p:cNvPicPr>
-            <a:picLocks noChangeAspect="1"/>
-          </p:cNvPicPr>
-          <p:nvPr/>
-        </p:nvPicPr>
-        <p:blipFill>
-          <a:blip r:embed="rId4"/>
-          <a:stretch>
-            <a:fillRect/>
-          </a:stretch>
-        </p:blipFill>
-        <p:spPr>
-          <a:xfrm>
-            <a:off x="5462588" y="4824412"/>
+            <a:off x="4924425" y="4824412"/>
             <a:ext cx="642938" cy="109537"/>
           </a:xfrm>
           <a:prstGeom prst="rect">
@@ -7107,7 +7322,7 @@
       <p:pic>
         <p:nvPicPr>
           <p:cNvPr id="3" name="Image 1" descr="preencoded.png">
-            <a:hlinkClick r:id="rId3" tooltip="https://github.com/samquansah-algo/nbc-vct/blob/main/brand/NBC_Brand_Guide.pdf"/>
+            <a:hlinkClick r:id="rId3" tooltip="https://github.com/samquansah-algo/nbc-vct/blob/main/weekly-tactics/03-persona-ads/CAMPAIGN_PLAN.md#results"/>
           </p:cNvPr>
           <p:cNvPicPr>
             <a:picLocks noChangeAspect="1"/>
@@ -7122,7 +7337,33 @@
         </p:blipFill>
         <p:spPr>
           <a:xfrm>
-            <a:off x="5117306" y="4824412"/>
+            <a:off x="4595812" y="4824412"/>
+            <a:ext cx="595313" cy="109537"/>
+          </a:xfrm>
+          <a:prstGeom prst="rect">
+            <a:avLst/>
+          </a:prstGeom>
+        </p:spPr>
+      </p:pic>
+      <p:pic>
+        <p:nvPicPr>
+          <p:cNvPr id="4" name="Image 2" descr="preencoded.png">
+            <a:hlinkClick r:id="rId5" tooltip="https://github.com/samquansah-algo/nbc-vct/blob/main/brand/NBC_Brand_Guide.pdf"/>
+          </p:cNvPr>
+          <p:cNvPicPr>
+            <a:picLocks noChangeAspect="1"/>
+          </p:cNvPicPr>
+          <p:nvPr/>
+        </p:nvPicPr>
+        <p:blipFill>
+          <a:blip r:embed="rId4"/>
+          <a:stretch>
+            <a:fillRect/>
+          </a:stretch>
+        </p:blipFill>
+        <p:spPr>
+          <a:xfrm>
+            <a:off x="5253037" y="4824412"/>
             <a:ext cx="642938" cy="109537"/>
           </a:xfrm>
           <a:prstGeom prst="rect">
@@ -7197,7 +7438,7 @@
         </p:blipFill>
         <p:spPr>
           <a:xfrm>
-            <a:off x="4788694" y="4824412"/>
+            <a:off x="4595812" y="4824412"/>
             <a:ext cx="595313" cy="109537"/>
           </a:xfrm>
           <a:prstGeom prst="rect">
@@ -7223,7 +7464,7 @@
         </p:blipFill>
         <p:spPr>
           <a:xfrm>
-            <a:off x="5445919" y="4824412"/>
+            <a:off x="5253037" y="4824412"/>
             <a:ext cx="642938" cy="109537"/>
           </a:xfrm>
           <a:prstGeom prst="rect">
@@ -7283,7 +7524,7 @@
       <p:pic>
         <p:nvPicPr>
           <p:cNvPr id="3" name="Image 1" descr="preencoded.png">
-            <a:hlinkClick r:id="rId3" tooltip="https://github.com/samquansah-algo/nbc-vct/blob/main/tactics-milestones/DEADLINES.md"/>
+            <a:hlinkClick r:id="rId3" tooltip="https://github.com/samquansah-algo/nbc-vct/blob/main/tactics-milestones/WEEKLY_DECISION_RECORD.md"/>
           </p:cNvPr>
           <p:cNvPicPr>
             <a:picLocks noChangeAspect="1"/>
@@ -7298,8 +7539,8 @@
         </p:blipFill>
         <p:spPr>
           <a:xfrm>
-            <a:off x="4891088" y="4824412"/>
-            <a:ext cx="390525" cy="109537"/>
+            <a:off x="4579144" y="4824412"/>
+            <a:ext cx="628650" cy="109537"/>
           </a:xfrm>
           <a:prstGeom prst="rect">
             <a:avLst/>
@@ -7324,7 +7565,7 @@
         </p:blipFill>
         <p:spPr>
           <a:xfrm>
-            <a:off x="5343525" y="4824412"/>
+            <a:off x="5269706" y="4824412"/>
             <a:ext cx="642938" cy="109537"/>
           </a:xfrm>
           <a:prstGeom prst="rect">
@@ -7399,7 +7640,7 @@
         </p:blipFill>
         <p:spPr>
           <a:xfrm>
-            <a:off x="5117306" y="4824412"/>
+            <a:off x="4924425" y="4824412"/>
             <a:ext cx="642938" cy="109537"/>
           </a:xfrm>
           <a:prstGeom prst="rect">
@@ -7459,7 +7700,7 @@
       <p:pic>
         <p:nvPicPr>
           <p:cNvPr id="3" name="Image 1" descr="preencoded.png">
-            <a:hlinkClick r:id="rId3" tooltip="https://github.com/samquansah-algo/nbc-vct/tree/main/brand/motion/"/>
+            <a:hlinkClick r:id="rId3" tooltip="https://github.com/samquansah-algo/nbc-vct/blob/main/weekly-tactics/03-persona-ads/CAMPAIGN_PLAN.md"/>
           </p:cNvPr>
           <p:cNvPicPr>
             <a:picLocks noChangeAspect="1"/>
@@ -7474,8 +7715,8 @@
         </p:blipFill>
         <p:spPr>
           <a:xfrm>
-            <a:off x="2171700" y="2543175"/>
-            <a:ext cx="857250" cy="195263"/>
+            <a:off x="4595812" y="4824412"/>
+            <a:ext cx="595313" cy="109537"/>
           </a:xfrm>
           <a:prstGeom prst="rect">
             <a:avLst/>
@@ -7485,7 +7726,7 @@
       <p:pic>
         <p:nvPicPr>
           <p:cNvPr id="4" name="Image 2" descr="preencoded.png">
-            <a:hlinkClick r:id="rId5" tooltip="https://github.com/samquansah-algo/nbc-vct/tree/main/brand/motion/"/>
+            <a:hlinkClick r:id="rId5" tooltip="https://github.com/samquansah-algo/nbc-vct/blob/main/brand/NBC_Brand_Guide.pdf"/>
           </p:cNvPr>
           <p:cNvPicPr>
             <a:picLocks noChangeAspect="1"/>
@@ -7500,33 +7741,7 @@
         </p:blipFill>
         <p:spPr>
           <a:xfrm>
-            <a:off x="4822031" y="4824412"/>
-            <a:ext cx="528638" cy="109537"/>
-          </a:xfrm>
-          <a:prstGeom prst="rect">
-            <a:avLst/>
-          </a:prstGeom>
-        </p:spPr>
-      </p:pic>
-      <p:pic>
-        <p:nvPicPr>
-          <p:cNvPr id="5" name="Image 3" descr="preencoded.png">
-            <a:hlinkClick r:id="rId7" tooltip="https://github.com/samquansah-algo/nbc-vct/blob/main/brand/NBC_Brand_Guide.pdf"/>
-          </p:cNvPr>
-          <p:cNvPicPr>
-            <a:picLocks noChangeAspect="1"/>
-          </p:cNvPicPr>
-          <p:nvPr/>
-        </p:nvPicPr>
-        <p:blipFill>
-          <a:blip r:embed="rId6"/>
-          <a:stretch>
-            <a:fillRect/>
-          </a:stretch>
-        </p:blipFill>
-        <p:spPr>
-          <a:xfrm>
-            <a:off x="5412581" y="4824412"/>
+            <a:off x="5253037" y="4824412"/>
             <a:ext cx="642938" cy="109537"/>
           </a:xfrm>
           <a:prstGeom prst="rect">
@@ -7586,7 +7801,7 @@
       <p:pic>
         <p:nvPicPr>
           <p:cNvPr id="3" name="Image 1" descr="preencoded.png">
-            <a:hlinkClick r:id="rId3" tooltip="https://github.com/samquansah-algo/nbc-vct/blob/main/thesis/NBC_Thesis_and_Strategy_v5.md"/>
+            <a:hlinkClick r:id="rId3" tooltip="https://github.com/samquansah-algo/nbc-vct/blob/main/tactics-milestones/DEADLINES.md"/>
           </p:cNvPr>
           <p:cNvPicPr>
             <a:picLocks noChangeAspect="1"/>
@@ -7601,8 +7816,8 @@
         </p:blipFill>
         <p:spPr>
           <a:xfrm>
-            <a:off x="4907756" y="4824412"/>
-            <a:ext cx="357188" cy="109537"/>
+            <a:off x="4698206" y="4824412"/>
+            <a:ext cx="390525" cy="109537"/>
           </a:xfrm>
           <a:prstGeom prst="rect">
             <a:avLst/>
@@ -7627,7 +7842,7 @@
         </p:blipFill>
         <p:spPr>
           <a:xfrm>
-            <a:off x="5326856" y="4824412"/>
+            <a:off x="5150644" y="4824412"/>
             <a:ext cx="642938" cy="109537"/>
           </a:xfrm>
           <a:prstGeom prst="rect">
@@ -7687,7 +7902,7 @@
       <p:pic>
         <p:nvPicPr>
           <p:cNvPr id="3" name="Image 1" descr="preencoded.png">
-            <a:hlinkClick r:id="rId3" tooltip="https://github.com/samquansah-algo/nbc-tnt"/>
+            <a:hlinkClick r:id="rId3" tooltip="https://github.com/samquansah-algo/nbc-vct/blob/main/brand/NBC_Brand_Guide.pdf"/>
           </p:cNvPr>
           <p:cNvPicPr>
             <a:picLocks noChangeAspect="1"/>
@@ -7702,33 +7917,7 @@
         </p:blipFill>
         <p:spPr>
           <a:xfrm>
-            <a:off x="4693444" y="4824412"/>
-            <a:ext cx="785813" cy="109537"/>
-          </a:xfrm>
-          <a:prstGeom prst="rect">
-            <a:avLst/>
-          </a:prstGeom>
-        </p:spPr>
-      </p:pic>
-      <p:pic>
-        <p:nvPicPr>
-          <p:cNvPr id="4" name="Image 2" descr="preencoded.png">
-            <a:hlinkClick r:id="rId5" tooltip="https://github.com/samquansah-algo/nbc-vct/blob/main/brand/NBC_Brand_Guide.pdf"/>
-          </p:cNvPr>
-          <p:cNvPicPr>
-            <a:picLocks noChangeAspect="1"/>
-          </p:cNvPicPr>
-          <p:nvPr/>
-        </p:nvPicPr>
-        <p:blipFill>
-          <a:blip r:embed="rId4"/>
-          <a:stretch>
-            <a:fillRect/>
-          </a:stretch>
-        </p:blipFill>
-        <p:spPr>
-          <a:xfrm>
-            <a:off x="5541169" y="4824412"/>
+            <a:off x="4924425" y="4824412"/>
             <a:ext cx="642938" cy="109537"/>
           </a:xfrm>
           <a:prstGeom prst="rect">
@@ -7803,7 +7992,7 @@
         </p:blipFill>
         <p:spPr>
           <a:xfrm>
-            <a:off x="5141119" y="4824412"/>
+            <a:off x="4948238" y="4824412"/>
             <a:ext cx="642938" cy="109537"/>
           </a:xfrm>
           <a:prstGeom prst="rect">
@@ -7863,7 +8052,7 @@
       <p:pic>
         <p:nvPicPr>
           <p:cNvPr id="3" name="Image 1" descr="preencoded.png">
-            <a:hlinkClick r:id="rId3" tooltip="https://github.com/samquansah-algo/nbc-vct/blob/main/tactics-milestones/DEADLINES.md"/>
+            <a:hlinkClick r:id="rId3" tooltip="https://github.com/samquansah-algo/nbc-vct/blob/main/thesis/NBC_Thesis_and_Strategy_v5.md"/>
           </p:cNvPr>
           <p:cNvPicPr>
             <a:picLocks noChangeAspect="1"/>
@@ -7878,8 +8067,8 @@
         </p:blipFill>
         <p:spPr>
           <a:xfrm>
-            <a:off x="4891088" y="4824412"/>
-            <a:ext cx="390525" cy="109537"/>
+            <a:off x="4714875" y="4824412"/>
+            <a:ext cx="357188" cy="109537"/>
           </a:xfrm>
           <a:prstGeom prst="rect">
             <a:avLst/>
@@ -7904,7 +8093,7 @@
         </p:blipFill>
         <p:spPr>
           <a:xfrm>
-            <a:off x="5343525" y="4824412"/>
+            <a:off x="5133975" y="4824412"/>
             <a:ext cx="642938" cy="109537"/>
           </a:xfrm>
           <a:prstGeom prst="rect">
@@ -7964,6 +8153,335 @@
       <p:pic>
         <p:nvPicPr>
           <p:cNvPr id="3" name="Image 1" descr="preencoded.png">
+            <a:hlinkClick r:id="rId3" tooltip="https://github.com/samquansah-algo/nbc-tnt"/>
+          </p:cNvPr>
+          <p:cNvPicPr>
+            <a:picLocks noChangeAspect="1"/>
+          </p:cNvPicPr>
+          <p:nvPr/>
+        </p:nvPicPr>
+        <p:blipFill>
+          <a:blip r:embed="rId2"/>
+          <a:stretch>
+            <a:fillRect/>
+          </a:stretch>
+        </p:blipFill>
+        <p:spPr>
+          <a:xfrm>
+            <a:off x="4500563" y="4824412"/>
+            <a:ext cx="785813" cy="109537"/>
+          </a:xfrm>
+          <a:prstGeom prst="rect">
+            <a:avLst/>
+          </a:prstGeom>
+        </p:spPr>
+      </p:pic>
+      <p:pic>
+        <p:nvPicPr>
+          <p:cNvPr id="4" name="Image 2" descr="preencoded.png">
+            <a:hlinkClick r:id="rId5" tooltip="https://github.com/samquansah-algo/nbc-vct/blob/main/brand/NBC_Brand_Guide.pdf"/>
+          </p:cNvPr>
+          <p:cNvPicPr>
+            <a:picLocks noChangeAspect="1"/>
+          </p:cNvPicPr>
+          <p:nvPr/>
+        </p:nvPicPr>
+        <p:blipFill>
+          <a:blip r:embed="rId4"/>
+          <a:stretch>
+            <a:fillRect/>
+          </a:stretch>
+        </p:blipFill>
+        <p:spPr>
+          <a:xfrm>
+            <a:off x="5348288" y="4824412"/>
+            <a:ext cx="642938" cy="109537"/>
+          </a:xfrm>
+          <a:prstGeom prst="rect">
+            <a:avLst/>
+          </a:prstGeom>
+        </p:spPr>
+      </p:pic>
+    </p:spTree>
+  </p:cSld>
+  <p:clrMapOvr>
+    <a:masterClrMapping/>
+  </p:clrMapOvr>
+</p:sld>
+</file>
+
+<file path=ppt/slides/slide42.xml><?xml version="1.0" encoding="utf-8"?>
+<p:sld xmlns:a="http://schemas.openxmlformats.org/drawingml/2006/main" xmlns:r="http://schemas.openxmlformats.org/officeDocument/2006/relationships" xmlns:p="http://schemas.openxmlformats.org/presentationml/2006/main">
+  <p:cSld name="Slide 42">
+    <p:spTree>
+      <p:nvGrpSpPr>
+        <p:cNvPr id="1" name=""/>
+        <p:cNvGrpSpPr/>
+        <p:nvPr/>
+      </p:nvGrpSpPr>
+      <p:grpSpPr>
+        <a:xfrm>
+          <a:off x="0" y="0"/>
+          <a:ext cx="0" cy="0"/>
+          <a:chOff x="0" y="0"/>
+          <a:chExt cx="0" cy="0"/>
+        </a:xfrm>
+      </p:grpSpPr>
+      <p:pic>
+        <p:nvPicPr>
+          <p:cNvPr id="2" name="Image 0" descr="NBC market research slide 42">    </p:cNvPr>
+          <p:cNvPicPr>
+            <a:picLocks noChangeAspect="1"/>
+          </p:cNvPicPr>
+          <p:nvPr/>
+        </p:nvPicPr>
+        <p:blipFill>
+          <a:blip r:embed="rId1"/>
+          <a:stretch>
+            <a:fillRect/>
+          </a:stretch>
+        </p:blipFill>
+        <p:spPr>
+          <a:xfrm>
+            <a:off x="0" y="0"/>
+            <a:ext cx="9144000" cy="5143500"/>
+          </a:xfrm>
+          <a:prstGeom prst="rect">
+            <a:avLst/>
+          </a:prstGeom>
+        </p:spPr>
+      </p:pic>
+      <p:pic>
+        <p:nvPicPr>
+          <p:cNvPr id="3" name="Image 1" descr="preencoded.png">
+            <a:hlinkClick r:id="rId3" tooltip="https://github.com/samquansah-algo/nbc-vct/tree/main/brand/motion/"/>
+          </p:cNvPr>
+          <p:cNvPicPr>
+            <a:picLocks noChangeAspect="1"/>
+          </p:cNvPicPr>
+          <p:nvPr/>
+        </p:nvPicPr>
+        <p:blipFill>
+          <a:blip r:embed="rId2"/>
+          <a:stretch>
+            <a:fillRect/>
+          </a:stretch>
+        </p:blipFill>
+        <p:spPr>
+          <a:xfrm>
+            <a:off x="1752600" y="2750344"/>
+            <a:ext cx="485775" cy="195263"/>
+          </a:xfrm>
+          <a:prstGeom prst="rect">
+            <a:avLst/>
+          </a:prstGeom>
+        </p:spPr>
+      </p:pic>
+      <p:pic>
+        <p:nvPicPr>
+          <p:cNvPr id="4" name="Image 2" descr="preencoded.png">
+            <a:hlinkClick r:id="rId5" tooltip="https://github.com/samquansah-algo/nbc-vct/tree/main/brand/motion/"/>
+          </p:cNvPr>
+          <p:cNvPicPr>
+            <a:picLocks noChangeAspect="1"/>
+          </p:cNvPicPr>
+          <p:nvPr/>
+        </p:nvPicPr>
+        <p:blipFill>
+          <a:blip r:embed="rId4"/>
+          <a:stretch>
+            <a:fillRect/>
+          </a:stretch>
+        </p:blipFill>
+        <p:spPr>
+          <a:xfrm>
+            <a:off x="4745831" y="4824412"/>
+            <a:ext cx="295275" cy="109537"/>
+          </a:xfrm>
+          <a:prstGeom prst="rect">
+            <a:avLst/>
+          </a:prstGeom>
+        </p:spPr>
+      </p:pic>
+      <p:pic>
+        <p:nvPicPr>
+          <p:cNvPr id="5" name="Image 3" descr="preencoded.png">
+            <a:hlinkClick r:id="rId7" tooltip="https://github.com/samquansah-algo/nbc-vct/blob/main/brand/NBC_Brand_Guide.pdf"/>
+          </p:cNvPr>
+          <p:cNvPicPr>
+            <a:picLocks noChangeAspect="1"/>
+          </p:cNvPicPr>
+          <p:nvPr/>
+        </p:nvPicPr>
+        <p:blipFill>
+          <a:blip r:embed="rId6"/>
+          <a:stretch>
+            <a:fillRect/>
+          </a:stretch>
+        </p:blipFill>
+        <p:spPr>
+          <a:xfrm>
+            <a:off x="5103019" y="4824412"/>
+            <a:ext cx="642938" cy="109537"/>
+          </a:xfrm>
+          <a:prstGeom prst="rect">
+            <a:avLst/>
+          </a:prstGeom>
+        </p:spPr>
+      </p:pic>
+    </p:spTree>
+  </p:cSld>
+  <p:clrMapOvr>
+    <a:masterClrMapping/>
+  </p:clrMapOvr>
+</p:sld>
+</file>
+
+<file path=ppt/slides/slide43.xml><?xml version="1.0" encoding="utf-8"?>
+<p:sld xmlns:a="http://schemas.openxmlformats.org/drawingml/2006/main" xmlns:r="http://schemas.openxmlformats.org/officeDocument/2006/relationships" xmlns:p="http://schemas.openxmlformats.org/presentationml/2006/main">
+  <p:cSld name="Slide 43">
+    <p:spTree>
+      <p:nvGrpSpPr>
+        <p:cNvPr id="1" name=""/>
+        <p:cNvGrpSpPr/>
+        <p:nvPr/>
+      </p:nvGrpSpPr>
+      <p:grpSpPr>
+        <a:xfrm>
+          <a:off x="0" y="0"/>
+          <a:ext cx="0" cy="0"/>
+          <a:chOff x="0" y="0"/>
+          <a:chExt cx="0" cy="0"/>
+        </a:xfrm>
+      </p:grpSpPr>
+      <p:pic>
+        <p:nvPicPr>
+          <p:cNvPr id="2" name="Image 0" descr="NBC market research slide 43">    </p:cNvPr>
+          <p:cNvPicPr>
+            <a:picLocks noChangeAspect="1"/>
+          </p:cNvPicPr>
+          <p:nvPr/>
+        </p:nvPicPr>
+        <p:blipFill>
+          <a:blip r:embed="rId1"/>
+          <a:stretch>
+            <a:fillRect/>
+          </a:stretch>
+        </p:blipFill>
+        <p:spPr>
+          <a:xfrm>
+            <a:off x="0" y="0"/>
+            <a:ext cx="9144000" cy="5143500"/>
+          </a:xfrm>
+          <a:prstGeom prst="rect">
+            <a:avLst/>
+          </a:prstGeom>
+        </p:spPr>
+      </p:pic>
+      <p:pic>
+        <p:nvPicPr>
+          <p:cNvPr id="3" name="Image 1" descr="preencoded.png">
+            <a:hlinkClick r:id="rId3" tooltip="https://github.com/samquansah-algo/nbc-vct/blob/main/tactics-milestones/DEADLINES.md"/>
+          </p:cNvPr>
+          <p:cNvPicPr>
+            <a:picLocks noChangeAspect="1"/>
+          </p:cNvPicPr>
+          <p:nvPr/>
+        </p:nvPicPr>
+        <p:blipFill>
+          <a:blip r:embed="rId2"/>
+          <a:stretch>
+            <a:fillRect/>
+          </a:stretch>
+        </p:blipFill>
+        <p:spPr>
+          <a:xfrm>
+            <a:off x="4698206" y="4824412"/>
+            <a:ext cx="390525" cy="109537"/>
+          </a:xfrm>
+          <a:prstGeom prst="rect">
+            <a:avLst/>
+          </a:prstGeom>
+        </p:spPr>
+      </p:pic>
+      <p:pic>
+        <p:nvPicPr>
+          <p:cNvPr id="4" name="Image 2" descr="preencoded.png">
+            <a:hlinkClick r:id="rId5" tooltip="https://github.com/samquansah-algo/nbc-vct/blob/main/brand/NBC_Brand_Guide.pdf"/>
+          </p:cNvPr>
+          <p:cNvPicPr>
+            <a:picLocks noChangeAspect="1"/>
+          </p:cNvPicPr>
+          <p:nvPr/>
+        </p:nvPicPr>
+        <p:blipFill>
+          <a:blip r:embed="rId4"/>
+          <a:stretch>
+            <a:fillRect/>
+          </a:stretch>
+        </p:blipFill>
+        <p:spPr>
+          <a:xfrm>
+            <a:off x="5150644" y="4824412"/>
+            <a:ext cx="642938" cy="109537"/>
+          </a:xfrm>
+          <a:prstGeom prst="rect">
+            <a:avLst/>
+          </a:prstGeom>
+        </p:spPr>
+      </p:pic>
+    </p:spTree>
+  </p:cSld>
+  <p:clrMapOvr>
+    <a:masterClrMapping/>
+  </p:clrMapOvr>
+</p:sld>
+</file>
+
+<file path=ppt/slides/slide44.xml><?xml version="1.0" encoding="utf-8"?>
+<p:sld xmlns:a="http://schemas.openxmlformats.org/drawingml/2006/main" xmlns:r="http://schemas.openxmlformats.org/officeDocument/2006/relationships" xmlns:p="http://schemas.openxmlformats.org/presentationml/2006/main">
+  <p:cSld name="Slide 44">
+    <p:spTree>
+      <p:nvGrpSpPr>
+        <p:cNvPr id="1" name=""/>
+        <p:cNvGrpSpPr/>
+        <p:nvPr/>
+      </p:nvGrpSpPr>
+      <p:grpSpPr>
+        <a:xfrm>
+          <a:off x="0" y="0"/>
+          <a:ext cx="0" cy="0"/>
+          <a:chOff x="0" y="0"/>
+          <a:chExt cx="0" cy="0"/>
+        </a:xfrm>
+      </p:grpSpPr>
+      <p:pic>
+        <p:nvPicPr>
+          <p:cNvPr id="2" name="Image 0" descr="NBC market research slide 44">    </p:cNvPr>
+          <p:cNvPicPr>
+            <a:picLocks noChangeAspect="1"/>
+          </p:cNvPicPr>
+          <p:nvPr/>
+        </p:nvPicPr>
+        <p:blipFill>
+          <a:blip r:embed="rId1"/>
+          <a:stretch>
+            <a:fillRect/>
+          </a:stretch>
+        </p:blipFill>
+        <p:spPr>
+          <a:xfrm>
+            <a:off x="0" y="0"/>
+            <a:ext cx="9144000" cy="5143500"/>
+          </a:xfrm>
+          <a:prstGeom prst="rect">
+            <a:avLst/>
+          </a:prstGeom>
+        </p:spPr>
+      </p:pic>
+      <p:pic>
+        <p:nvPicPr>
+          <p:cNvPr id="3" name="Image 1" descr="preencoded.png">
             <a:hlinkClick r:id="rId3" tooltip="mailto:samquansah@gse.harvard.edu"/>
           </p:cNvPr>
           <p:cNvPicPr>
@@ -8084,7 +8602,7 @@
         <p:spPr>
           <a:xfrm>
             <a:off x="3648075" y="4193828"/>
-            <a:ext cx="695325" cy="157163"/>
+            <a:ext cx="390525" cy="157163"/>
           </a:xfrm>
           <a:prstGeom prst="rect">
             <a:avLst/>
@@ -8158,7 +8676,7 @@
         </p:blipFill>
         <p:spPr>
           <a:xfrm>
-            <a:off x="4914900" y="4824412"/>
+            <a:off x="4722019" y="4824412"/>
             <a:ext cx="390525" cy="109537"/>
           </a:xfrm>
           <a:prstGeom prst="rect">
@@ -8184,7 +8702,7 @@
         </p:blipFill>
         <p:spPr>
           <a:xfrm>
-            <a:off x="5367337" y="4824412"/>
+            <a:off x="5174456" y="4824412"/>
             <a:ext cx="642938" cy="109537"/>
           </a:xfrm>
           <a:prstGeom prst="rect">
@@ -8259,7 +8777,7 @@
         </p:blipFill>
         <p:spPr>
           <a:xfrm>
-            <a:off x="4581525" y="4824412"/>
+            <a:off x="4388644" y="4824412"/>
             <a:ext cx="1057275" cy="109537"/>
           </a:xfrm>
           <a:prstGeom prst="rect">
@@ -8285,7 +8803,7 @@
         </p:blipFill>
         <p:spPr>
           <a:xfrm>
-            <a:off x="5700713" y="4824412"/>
+            <a:off x="5507831" y="4824412"/>
             <a:ext cx="642938" cy="109537"/>
           </a:xfrm>
           <a:prstGeom prst="rect">
@@ -8360,7 +8878,7 @@
         </p:blipFill>
         <p:spPr>
           <a:xfrm>
-            <a:off x="4581525" y="4824412"/>
+            <a:off x="4388644" y="4824412"/>
             <a:ext cx="1057275" cy="109537"/>
           </a:xfrm>
           <a:prstGeom prst="rect">
@@ -8386,7 +8904,7 @@
         </p:blipFill>
         <p:spPr>
           <a:xfrm>
-            <a:off x="5700713" y="4824412"/>
+            <a:off x="5507831" y="4824412"/>
             <a:ext cx="642938" cy="109537"/>
           </a:xfrm>
           <a:prstGeom prst="rect">
@@ -8446,7 +8964,7 @@
       <p:pic>
         <p:nvPicPr>
           <p:cNvPr id="3" name="Image 1" descr="preencoded.png">
-            <a:hlinkClick r:id="rId3" tooltip="https://github.com/samquansah-algo/nbc-vct/blob/main/tactics-milestones/DEADLINES.md"/>
+            <a:hlinkClick r:id="rId3" tooltip="https://github.com/samquansah-algo/nbc-vct/blob/main/README.md"/>
           </p:cNvPr>
           <p:cNvPicPr>
             <a:picLocks noChangeAspect="1"/>
@@ -8461,8 +8979,8 @@
         </p:blipFill>
         <p:spPr>
           <a:xfrm>
-            <a:off x="4705350" y="4824412"/>
-            <a:ext cx="390525" cy="109537"/>
+            <a:off x="4388644" y="4824412"/>
+            <a:ext cx="1057275" cy="109537"/>
           </a:xfrm>
           <a:prstGeom prst="rect">
             <a:avLst/>
@@ -8472,7 +8990,7 @@
       <p:pic>
         <p:nvPicPr>
           <p:cNvPr id="4" name="Image 2" descr="preencoded.png">
-            <a:hlinkClick r:id="rId5" tooltip="https://github.com/samquansah-algo/nbc-vct/blob/main/thesis/NBC_Thesis_and_Strategy_v5.md"/>
+            <a:hlinkClick r:id="rId5" tooltip="https://github.com/samquansah-algo/nbc-vct/blob/main/brand/NBC_Brand_Guide.pdf"/>
           </p:cNvPr>
           <p:cNvPicPr>
             <a:picLocks noChangeAspect="1"/>
@@ -8487,33 +9005,7 @@
         </p:blipFill>
         <p:spPr>
           <a:xfrm>
-            <a:off x="5157788" y="4824412"/>
-            <a:ext cx="357188" cy="109537"/>
-          </a:xfrm>
-          <a:prstGeom prst="rect">
-            <a:avLst/>
-          </a:prstGeom>
-        </p:spPr>
-      </p:pic>
-      <p:pic>
-        <p:nvPicPr>
-          <p:cNvPr id="5" name="Image 3" descr="preencoded.png">
-            <a:hlinkClick r:id="rId7" tooltip="https://github.com/samquansah-algo/nbc-vct/blob/main/brand/NBC_Brand_Guide.pdf"/>
-          </p:cNvPr>
-          <p:cNvPicPr>
-            <a:picLocks noChangeAspect="1"/>
-          </p:cNvPicPr>
-          <p:nvPr/>
-        </p:nvPicPr>
-        <p:blipFill>
-          <a:blip r:embed="rId6"/>
-          <a:stretch>
-            <a:fillRect/>
-          </a:stretch>
-        </p:blipFill>
-        <p:spPr>
-          <a:xfrm>
-            <a:off x="5576888" y="4824412"/>
+            <a:off x="5507831" y="4824412"/>
             <a:ext cx="642938" cy="109537"/>
           </a:xfrm>
           <a:prstGeom prst="rect">
@@ -8573,7 +9065,7 @@
       <p:pic>
         <p:nvPicPr>
           <p:cNvPr id="3" name="Image 1" descr="preencoded.png">
-            <a:hlinkClick r:id="rId3" tooltip="https://github.com/samquansah-algo/nbc-vct/blob/main/brand/NBC_Brand_Guide.pdf"/>
+            <a:hlinkClick r:id="rId3" tooltip="https://github.com/samquansah-algo/nbc-vct/blob/main/README.md"/>
           </p:cNvPr>
           <p:cNvPicPr>
             <a:picLocks noChangeAspect="1"/>
@@ -8588,7 +9080,33 @@
         </p:blipFill>
         <p:spPr>
           <a:xfrm>
-            <a:off x="5141119" y="4824412"/>
+            <a:off x="4388644" y="4824412"/>
+            <a:ext cx="1057275" cy="109537"/>
+          </a:xfrm>
+          <a:prstGeom prst="rect">
+            <a:avLst/>
+          </a:prstGeom>
+        </p:spPr>
+      </p:pic>
+      <p:pic>
+        <p:nvPicPr>
+          <p:cNvPr id="4" name="Image 2" descr="preencoded.png">
+            <a:hlinkClick r:id="rId5" tooltip="https://github.com/samquansah-algo/nbc-vct/blob/main/brand/NBC_Brand_Guide.pdf"/>
+          </p:cNvPr>
+          <p:cNvPicPr>
+            <a:picLocks noChangeAspect="1"/>
+          </p:cNvPicPr>
+          <p:nvPr/>
+        </p:nvPicPr>
+        <p:blipFill>
+          <a:blip r:embed="rId4"/>
+          <a:stretch>
+            <a:fillRect/>
+          </a:stretch>
+        </p:blipFill>
+        <p:spPr>
+          <a:xfrm>
+            <a:off x="5507831" y="4824412"/>
             <a:ext cx="642938" cy="109537"/>
           </a:xfrm>
           <a:prstGeom prst="rect">

</xml_diff>